<commit_message>
Deck: Yang's revisions (new masked-prompt slide, rates + outlook combined, map moved, next steps, income appendix)
Co-Authored-By: Claude Opus 5.5 <noreply@anthropic.com>
Claude-Session: https://claude.ai/code/session_01MGxrqNkCGgpin2owaUrbi7
</commit_message>
<xml_diff>
--- a/slides/LA_home_values_appendix_crime.pptx
+++ b/slides/LA_home_values_appendix_crime.pptx
@@ -6,6 +6,7 @@
   </p:sldMasterIdLst>
   <p:sldIdLst>
     <p:sldId id="256" r:id="rId7"/>
+    <p:sldId id="257" r:id="rId9"/>
   </p:sldIdLst>
   <p:sldSz cx="9144000" cy="5143500" type="screen4x3"/>
   <p:notesSz cx="6858000" cy="9144000"/>
@@ -503,6 +504,76 @@
           <a:p>
             <a:r>
               <a:t>Appendix slide, only if Professor Yu asks about crime. Two reasons it is not in the main talk: it covers only part of our neighborhoods, and it does not help predict prices. LAPD data only covers the City of LA, so this is 91 neighborhoods. We counted crimes within 1.5 kilometers of each neighborhood per 1,000 residents, and split them into violent crime (murder, rape, robbery, aggravated assault) and property crime, using the FBI definitions so 2021 and 2025 count the same things. On the left, violent crime and home value go together strongly: safer neighborhoods cost more, correlation minus 0.68. But the question for forecasting is whether crime tells us anything beyond price. The middle and right panels compare neighborhoods at the same price level. Crime did not predict which neighborhoods fell more in 2022 and 2023, p equals 0.59, or which are rising over the last year, p equals 0.68. Without the price control, high-crime areas did grow less this year, but that is just because they are the cheaper areas, and cheaper areas grew less. Same answer for total crime and property crime.</a:t>
+            </a:r>
+          </a:p>
+        </p:txBody>
+      </p:sp>
+      <p:sp>
+        <p:nvSpPr>
+          <p:cNvPr id="4" name="Slide Number Placeholder 3"/>
+          <p:cNvSpPr>
+            <a:spLocks noGrp="1"/>
+          </p:cNvSpPr>
+          <p:nvPr>
+            <p:ph type="sldNum" idx="5" sz="quarter"/>
+          </p:nvPr>
+        </p:nvSpPr>
+        <p:spPr/>
+      </p:sp>
+    </p:spTree>
+  </p:cSld>
+  <p:clrMapOvr>
+    <a:masterClrMapping/>
+  </p:clrMapOvr>
+</p:notes>
+</file>
+
+<file path=ppt/notesSlides/notesSlide2.xml><?xml version="1.0" encoding="utf-8"?>
+<p:notes xmlns:a="http://schemas.openxmlformats.org/drawingml/2006/main" xmlns:p="http://schemas.openxmlformats.org/presentationml/2006/main" xmlns:r="http://schemas.openxmlformats.org/officeDocument/2006/relationships">
+  <p:cSld>
+    <p:spTree>
+      <p:nvGrpSpPr>
+        <p:cNvPr id="1" name=""/>
+        <p:cNvGrpSpPr/>
+        <p:nvPr/>
+      </p:nvGrpSpPr>
+      <p:grpSpPr>
+        <a:xfrm>
+          <a:off x="0" y="0"/>
+          <a:ext cx="0" cy="0"/>
+          <a:chOff x="0" y="0"/>
+          <a:chExt cx="0" cy="0"/>
+        </a:xfrm>
+      </p:grpSpPr>
+      <p:sp>
+        <p:nvSpPr>
+          <p:cNvPr id="2" name="Slide Image Placeholder 1"/>
+          <p:cNvSpPr>
+            <a:spLocks noGrp="1"/>
+          </p:cNvSpPr>
+          <p:nvPr>
+            <p:ph type="sldImg" idx="2"/>
+          </p:nvPr>
+        </p:nvSpPr>
+        <p:spPr/>
+      </p:sp>
+      <p:sp>
+        <p:nvSpPr>
+          <p:cNvPr id="3" name="Notes Placeholder 2"/>
+          <p:cNvSpPr>
+            <a:spLocks noGrp="1"/>
+          </p:cNvSpPr>
+          <p:nvPr>
+            <p:ph type="body" idx="3" sz="quarter"/>
+          </p:nvPr>
+        </p:nvSpPr>
+        <p:spPr/>
+        <p:txBody>
+          <a:bodyPr/>
+          <a:lstStyle/>
+          <a:p>
+            <a:r>
+              <a:t>Only if asked about income. We did use income, in the ZIP-level panel. We left it out of the monthly ARIMAX because IRS income is annual, only starts in 2011, and comes out with a lag, so it barely varies month to month. And when we tested lagged income growth out of sample in the panel, it did not help: RMSE 3.77 versus 3.79. So the monthly model uses the mortgage rate.</a:t>
             </a:r>
           </a:p>
         </p:txBody>
@@ -3871,6 +3942,926 @@
           </a:prstGeom>
         </p:spPr>
       </p:pic>
+    </p:spTree>
+  </p:cSld>
+  <p:clrMapOvr>
+    <a:masterClrMapping/>
+  </p:clrMapOvr>
+</p:sld>
+</file>
+
+<file path=ppt/slides/slide2.xml><?xml version="1.0" encoding="utf-8"?>
+<p:sld xmlns:a="http://schemas.openxmlformats.org/drawingml/2006/main" xmlns:p="http://schemas.openxmlformats.org/presentationml/2006/main" xmlns:r="http://schemas.openxmlformats.org/officeDocument/2006/relationships">
+  <p:cSld>
+    <p:bg>
+      <p:bgPr>
+        <a:solidFill>
+          <a:srgbClr val="FAF8F4"/>
+        </a:solidFill>
+        <a:effectLst/>
+      </p:bgPr>
+    </p:bg>
+    <p:spTree>
+      <p:nvGrpSpPr>
+        <p:cNvPr id="1" name=""/>
+        <p:cNvGrpSpPr/>
+        <p:nvPr/>
+      </p:nvGrpSpPr>
+      <p:grpSpPr/>
+      <p:sp>
+        <p:nvSpPr>
+          <p:cNvPr id="2" name="deckkit-chrome-title"/>
+          <p:cNvSpPr txBox="1"/>
+          <p:nvPr/>
+        </p:nvSpPr>
+        <p:spPr>
+          <a:xfrm>
+            <a:off x="502920" y="274320"/>
+            <a:ext cx="8138160" cy="274320"/>
+          </a:xfrm>
+          <a:prstGeom prst="rect">
+            <a:avLst/>
+          </a:prstGeom>
+          <a:noFill/>
+          <a:ln/>
+        </p:spPr>
+        <p:txBody>
+          <a:bodyPr wrap="square" anchor="t" lIns="25400" rIns="25400" tIns="25400" bIns="25400">
+            <a:spAutoFit/>
+          </a:bodyPr>
+          <a:lstStyle/>
+          <a:p>
+            <a:pPr algn="l">
+              <a:lnSpc>
+                <a:spcPct val="100000"/>
+              </a:lnSpc>
+              <a:spcBef>
+                <a:spcPts val="0"/>
+              </a:spcBef>
+              <a:spcAft>
+                <a:spcPts val="0"/>
+              </a:spcAft>
+            </a:pPr>
+            <a:r>
+              <a:rPr sz="1100" b="1" i="0">
+                <a:solidFill>
+                  <a:srgbClr val="1F6F8B"/>
+                </a:solidFill>
+                <a:latin typeface="Arial"/>
+              </a:rPr>
+              <a:t>APPENDIX · ONLY IF ASKED ABOUT INCOME</a:t>
+            </a:r>
+          </a:p>
+        </p:txBody>
+      </p:sp>
+      <p:sp>
+        <p:nvSpPr>
+          <p:cNvPr id="3" name="deckkit-chrome-title"/>
+          <p:cNvSpPr txBox="1"/>
+          <p:nvPr/>
+        </p:nvSpPr>
+        <p:spPr>
+          <a:xfrm>
+            <a:off x="502920" y="493776"/>
+            <a:ext cx="8138160" cy="640080"/>
+          </a:xfrm>
+          <a:prstGeom prst="rect">
+            <a:avLst/>
+          </a:prstGeom>
+          <a:noFill/>
+          <a:ln/>
+        </p:spPr>
+        <p:txBody>
+          <a:bodyPr wrap="square" anchor="t" lIns="25400" rIns="25400" tIns="25400" bIns="25400">
+            <a:spAutoFit/>
+          </a:bodyPr>
+          <a:lstStyle/>
+          <a:p>
+            <a:pPr algn="l">
+              <a:lnSpc>
+                <a:spcPct val="100000"/>
+              </a:lnSpc>
+              <a:spcBef>
+                <a:spcPts val="0"/>
+              </a:spcBef>
+              <a:spcAft>
+                <a:spcPts val="0"/>
+              </a:spcAft>
+            </a:pPr>
+            <a:r>
+              <a:rPr sz="2600" b="1" i="0">
+                <a:solidFill>
+                  <a:srgbClr val="16213E"/>
+                </a:solidFill>
+                <a:latin typeface="Arial"/>
+              </a:rPr>
+              <a:t>Why income is not in our monthly ARIMAX</a:t>
+            </a:r>
+          </a:p>
+        </p:txBody>
+      </p:sp>
+      <p:sp>
+        <p:nvSpPr>
+          <p:cNvPr id="4" name="deckkit-chrome-title"/>
+          <p:cNvSpPr/>
+          <p:nvPr/>
+        </p:nvSpPr>
+        <p:spPr>
+          <a:xfrm>
+            <a:off x="521207" y="1060704"/>
+            <a:ext cx="1005840" cy="41148"/>
+          </a:xfrm>
+          <a:prstGeom prst="rect">
+            <a:avLst/>
+          </a:prstGeom>
+          <a:solidFill>
+            <a:srgbClr val="1F6F8B"/>
+          </a:solidFill>
+          <a:ln>
+            <a:noFill/>
+          </a:ln>
+          <a:effectLst/>
+        </p:spPr>
+        <p:txBody>
+          <a:bodyPr rtlCol="0" anchor="ctr"/>
+          <a:lstStyle/>
+          <a:p>
+            <a:pPr algn="ctr"/>
+          </a:p>
+        </p:txBody>
+      </p:sp>
+      <p:sp>
+        <p:nvSpPr>
+          <p:cNvPr id="5" name="TextBox 4"/>
+          <p:cNvSpPr txBox="1"/>
+          <p:nvPr/>
+        </p:nvSpPr>
+        <p:spPr>
+          <a:xfrm>
+            <a:off x="502920" y="4823460"/>
+            <a:ext cx="5486400" cy="274320"/>
+          </a:xfrm>
+          <a:prstGeom prst="rect">
+            <a:avLst/>
+          </a:prstGeom>
+          <a:noFill/>
+          <a:ln/>
+        </p:spPr>
+        <p:txBody>
+          <a:bodyPr wrap="square" anchor="t" lIns="25400" rIns="25400" tIns="25400" bIns="25400">
+            <a:spAutoFit/>
+          </a:bodyPr>
+          <a:lstStyle/>
+          <a:p>
+            <a:pPr algn="l">
+              <a:lnSpc>
+                <a:spcPct val="100000"/>
+              </a:lnSpc>
+              <a:spcBef>
+                <a:spcPts val="0"/>
+              </a:spcBef>
+              <a:spcAft>
+                <a:spcPts val="0"/>
+              </a:spcAft>
+            </a:pPr>
+            <a:r>
+              <a:rPr sz="800" b="0" i="0">
+                <a:solidFill>
+                  <a:srgbClr val="6B6F76"/>
+                </a:solidFill>
+                <a:latin typeface="Arial"/>
+              </a:rPr>
+              <a:t>MGMTMSA 437 · Forecasting LA Home Values · Data: Zillow ZHVI, FRED, BLS</a:t>
+            </a:r>
+          </a:p>
+        </p:txBody>
+      </p:sp>
+      <p:sp>
+        <p:nvSpPr>
+          <p:cNvPr id="6" name="TextBox 5"/>
+          <p:cNvSpPr txBox="1"/>
+          <p:nvPr/>
+        </p:nvSpPr>
+        <p:spPr>
+          <a:xfrm>
+            <a:off x="8229600" y="4823460"/>
+            <a:ext cx="548640" cy="274320"/>
+          </a:xfrm>
+          <a:prstGeom prst="rect">
+            <a:avLst/>
+          </a:prstGeom>
+          <a:noFill/>
+          <a:ln/>
+        </p:spPr>
+        <p:txBody>
+          <a:bodyPr wrap="square" anchor="t" lIns="25400" rIns="25400" tIns="25400" bIns="25400">
+            <a:spAutoFit/>
+          </a:bodyPr>
+          <a:lstStyle/>
+          <a:p>
+            <a:pPr algn="r">
+              <a:lnSpc>
+                <a:spcPct val="100000"/>
+              </a:lnSpc>
+              <a:spcBef>
+                <a:spcPts val="0"/>
+              </a:spcBef>
+              <a:spcAft>
+                <a:spcPts val="0"/>
+              </a:spcAft>
+            </a:pPr>
+            <a:r>
+              <a:rPr sz="900" b="1" i="0">
+                <a:solidFill>
+                  <a:srgbClr val="6B6F76"/>
+                </a:solidFill>
+                <a:latin typeface="Arial"/>
+              </a:rPr>
+              <a:t>2</a:t>
+            </a:r>
+          </a:p>
+        </p:txBody>
+      </p:sp>
+      <p:sp>
+        <p:nvSpPr>
+          <p:cNvPr id="7" name="Rounded Rectangle 6"/>
+          <p:cNvSpPr/>
+          <p:nvPr/>
+        </p:nvSpPr>
+        <p:spPr>
+          <a:xfrm>
+            <a:off x="502920" y="1335024"/>
+            <a:ext cx="384048" cy="384048"/>
+          </a:xfrm>
+          <a:prstGeom prst="roundRect">
+            <a:avLst>
+              <a:gd name="adj" fmla="val 50000"/>
+            </a:avLst>
+          </a:prstGeom>
+          <a:solidFill>
+            <a:srgbClr val="1F6F8B"/>
+          </a:solidFill>
+          <a:ln>
+            <a:noFill/>
+          </a:ln>
+          <a:effectLst/>
+        </p:spPr>
+        <p:txBody>
+          <a:bodyPr rtlCol="0" anchor="ctr"/>
+          <a:lstStyle/>
+          <a:p>
+            <a:pPr algn="ctr"/>
+          </a:p>
+        </p:txBody>
+      </p:sp>
+      <p:sp>
+        <p:nvSpPr>
+          <p:cNvPr id="8" name="TextBox 7"/>
+          <p:cNvSpPr txBox="1"/>
+          <p:nvPr/>
+        </p:nvSpPr>
+        <p:spPr>
+          <a:xfrm>
+            <a:off x="502920" y="1335024"/>
+            <a:ext cx="384048" cy="384048"/>
+          </a:xfrm>
+          <a:prstGeom prst="rect">
+            <a:avLst/>
+          </a:prstGeom>
+          <a:noFill/>
+          <a:ln/>
+        </p:spPr>
+        <p:txBody>
+          <a:bodyPr wrap="square" anchor="ctr" lIns="25400" rIns="25400" tIns="25400" bIns="25400">
+            <a:spAutoFit/>
+          </a:bodyPr>
+          <a:lstStyle/>
+          <a:p>
+            <a:pPr algn="ctr">
+              <a:lnSpc>
+                <a:spcPct val="100000"/>
+              </a:lnSpc>
+              <a:spcBef>
+                <a:spcPts val="0"/>
+              </a:spcBef>
+              <a:spcAft>
+                <a:spcPts val="0"/>
+              </a:spcAft>
+            </a:pPr>
+            <a:r>
+              <a:rPr sz="1400" b="1" i="0">
+                <a:solidFill>
+                  <a:srgbClr val="FFFFFF"/>
+                </a:solidFill>
+                <a:latin typeface="Arial"/>
+              </a:rPr>
+              <a:t>01</a:t>
+            </a:r>
+          </a:p>
+        </p:txBody>
+      </p:sp>
+      <p:sp>
+        <p:nvSpPr>
+          <p:cNvPr id="9" name="TextBox 8"/>
+          <p:cNvSpPr txBox="1"/>
+          <p:nvPr/>
+        </p:nvSpPr>
+        <p:spPr>
+          <a:xfrm>
+            <a:off x="1051560" y="1316736"/>
+            <a:ext cx="7589520" cy="292608"/>
+          </a:xfrm>
+          <a:prstGeom prst="rect">
+            <a:avLst/>
+          </a:prstGeom>
+          <a:noFill/>
+          <a:ln/>
+        </p:spPr>
+        <p:txBody>
+          <a:bodyPr wrap="square" anchor="t" lIns="25400" rIns="25400" tIns="25400" bIns="25400">
+            <a:spAutoFit/>
+          </a:bodyPr>
+          <a:lstStyle/>
+          <a:p>
+            <a:pPr algn="l">
+              <a:lnSpc>
+                <a:spcPct val="100000"/>
+              </a:lnSpc>
+              <a:spcBef>
+                <a:spcPts val="0"/>
+              </a:spcBef>
+              <a:spcAft>
+                <a:spcPts val="0"/>
+              </a:spcAft>
+            </a:pPr>
+            <a:r>
+              <a:rPr sz="1450" b="1" i="0">
+                <a:solidFill>
+                  <a:srgbClr val="16213E"/>
+                </a:solidFill>
+                <a:latin typeface="Arial"/>
+              </a:rPr>
+              <a:t>Used in the ZIP-level panel</a:t>
+            </a:r>
+          </a:p>
+        </p:txBody>
+      </p:sp>
+      <p:sp>
+        <p:nvSpPr>
+          <p:cNvPr id="10" name="TextBox 9"/>
+          <p:cNvSpPr txBox="1"/>
+          <p:nvPr/>
+        </p:nvSpPr>
+        <p:spPr>
+          <a:xfrm>
+            <a:off x="1051560" y="1609344"/>
+            <a:ext cx="7589520" cy="548640"/>
+          </a:xfrm>
+          <a:prstGeom prst="rect">
+            <a:avLst/>
+          </a:prstGeom>
+          <a:noFill/>
+          <a:ln/>
+        </p:spPr>
+        <p:txBody>
+          <a:bodyPr wrap="square" anchor="t" lIns="25400" rIns="25400" tIns="25400" bIns="25400">
+            <a:spAutoFit/>
+          </a:bodyPr>
+          <a:lstStyle/>
+          <a:p>
+            <a:pPr algn="l">
+              <a:lnSpc>
+                <a:spcPct val="102000"/>
+              </a:lnSpc>
+              <a:spcBef>
+                <a:spcPts val="0"/>
+              </a:spcBef>
+              <a:spcAft>
+                <a:spcPts val="0"/>
+              </a:spcAft>
+            </a:pPr>
+            <a:r>
+              <a:rPr sz="1150" b="0" i="0">
+                <a:solidFill>
+                  <a:srgbClr val="3D4A5C"/>
+                </a:solidFill>
+                <a:latin typeface="Arial"/>
+              </a:rPr>
+              <a:t>Income enters the cross-sectional panel analysis across ZIP codes.</a:t>
+            </a:r>
+          </a:p>
+        </p:txBody>
+      </p:sp>
+      <p:sp>
+        <p:nvSpPr>
+          <p:cNvPr id="11" name="Rounded Rectangle 10"/>
+          <p:cNvSpPr/>
+          <p:nvPr/>
+        </p:nvSpPr>
+        <p:spPr>
+          <a:xfrm>
+            <a:off x="502920" y="1993392"/>
+            <a:ext cx="384048" cy="384048"/>
+          </a:xfrm>
+          <a:prstGeom prst="roundRect">
+            <a:avLst>
+              <a:gd name="adj" fmla="val 50000"/>
+            </a:avLst>
+          </a:prstGeom>
+          <a:solidFill>
+            <a:srgbClr val="1F6F8B"/>
+          </a:solidFill>
+          <a:ln>
+            <a:noFill/>
+          </a:ln>
+          <a:effectLst/>
+        </p:spPr>
+        <p:txBody>
+          <a:bodyPr rtlCol="0" anchor="ctr"/>
+          <a:lstStyle/>
+          <a:p>
+            <a:pPr algn="ctr"/>
+          </a:p>
+        </p:txBody>
+      </p:sp>
+      <p:sp>
+        <p:nvSpPr>
+          <p:cNvPr id="12" name="TextBox 11"/>
+          <p:cNvSpPr txBox="1"/>
+          <p:nvPr/>
+        </p:nvSpPr>
+        <p:spPr>
+          <a:xfrm>
+            <a:off x="502920" y="1993392"/>
+            <a:ext cx="384048" cy="384048"/>
+          </a:xfrm>
+          <a:prstGeom prst="rect">
+            <a:avLst/>
+          </a:prstGeom>
+          <a:noFill/>
+          <a:ln/>
+        </p:spPr>
+        <p:txBody>
+          <a:bodyPr wrap="square" anchor="ctr" lIns="25400" rIns="25400" tIns="25400" bIns="25400">
+            <a:spAutoFit/>
+          </a:bodyPr>
+          <a:lstStyle/>
+          <a:p>
+            <a:pPr algn="ctr">
+              <a:lnSpc>
+                <a:spcPct val="100000"/>
+              </a:lnSpc>
+              <a:spcBef>
+                <a:spcPts val="0"/>
+              </a:spcBef>
+              <a:spcAft>
+                <a:spcPts val="0"/>
+              </a:spcAft>
+            </a:pPr>
+            <a:r>
+              <a:rPr sz="1400" b="1" i="0">
+                <a:solidFill>
+                  <a:srgbClr val="FFFFFF"/>
+                </a:solidFill>
+                <a:latin typeface="Arial"/>
+              </a:rPr>
+              <a:t>02</a:t>
+            </a:r>
+          </a:p>
+        </p:txBody>
+      </p:sp>
+      <p:sp>
+        <p:nvSpPr>
+          <p:cNvPr id="13" name="TextBox 12"/>
+          <p:cNvSpPr txBox="1"/>
+          <p:nvPr/>
+        </p:nvSpPr>
+        <p:spPr>
+          <a:xfrm>
+            <a:off x="1051560" y="1975104"/>
+            <a:ext cx="7589520" cy="292608"/>
+          </a:xfrm>
+          <a:prstGeom prst="rect">
+            <a:avLst/>
+          </a:prstGeom>
+          <a:noFill/>
+          <a:ln/>
+        </p:spPr>
+        <p:txBody>
+          <a:bodyPr wrap="square" anchor="t" lIns="25400" rIns="25400" tIns="25400" bIns="25400">
+            <a:spAutoFit/>
+          </a:bodyPr>
+          <a:lstStyle/>
+          <a:p>
+            <a:pPr algn="l">
+              <a:lnSpc>
+                <a:spcPct val="100000"/>
+              </a:lnSpc>
+              <a:spcBef>
+                <a:spcPts val="0"/>
+              </a:spcBef>
+              <a:spcAft>
+                <a:spcPts val="0"/>
+              </a:spcAft>
+            </a:pPr>
+            <a:r>
+              <a:rPr sz="1450" b="1" i="0">
+                <a:solidFill>
+                  <a:srgbClr val="16213E"/>
+                </a:solidFill>
+                <a:latin typeface="Arial"/>
+              </a:rPr>
+              <a:t>Too slow for a monthly model</a:t>
+            </a:r>
+          </a:p>
+        </p:txBody>
+      </p:sp>
+      <p:sp>
+        <p:nvSpPr>
+          <p:cNvPr id="14" name="TextBox 13"/>
+          <p:cNvSpPr txBox="1"/>
+          <p:nvPr/>
+        </p:nvSpPr>
+        <p:spPr>
+          <a:xfrm>
+            <a:off x="1051560" y="2267712"/>
+            <a:ext cx="7589520" cy="548640"/>
+          </a:xfrm>
+          <a:prstGeom prst="rect">
+            <a:avLst/>
+          </a:prstGeom>
+          <a:noFill/>
+          <a:ln/>
+        </p:spPr>
+        <p:txBody>
+          <a:bodyPr wrap="square" anchor="t" lIns="25400" rIns="25400" tIns="25400" bIns="25400">
+            <a:spAutoFit/>
+          </a:bodyPr>
+          <a:lstStyle/>
+          <a:p>
+            <a:pPr algn="l">
+              <a:lnSpc>
+                <a:spcPct val="102000"/>
+              </a:lnSpc>
+              <a:spcBef>
+                <a:spcPts val="0"/>
+              </a:spcBef>
+              <a:spcAft>
+                <a:spcPts val="0"/>
+              </a:spcAft>
+            </a:pPr>
+            <a:r>
+              <a:rPr sz="1150" b="0" i="0">
+                <a:solidFill>
+                  <a:srgbClr val="3D4A5C"/>
+                </a:solidFill>
+                <a:latin typeface="Arial"/>
+              </a:rPr>
+              <a:t>IRS income is annual, starts in 2011 and is released with a lag, so it adds little month-to-month variation.</a:t>
+            </a:r>
+          </a:p>
+        </p:txBody>
+      </p:sp>
+      <p:sp>
+        <p:nvSpPr>
+          <p:cNvPr id="15" name="Rounded Rectangle 14"/>
+          <p:cNvSpPr/>
+          <p:nvPr/>
+        </p:nvSpPr>
+        <p:spPr>
+          <a:xfrm>
+            <a:off x="502920" y="2651760"/>
+            <a:ext cx="384048" cy="384048"/>
+          </a:xfrm>
+          <a:prstGeom prst="roundRect">
+            <a:avLst>
+              <a:gd name="adj" fmla="val 50000"/>
+            </a:avLst>
+          </a:prstGeom>
+          <a:solidFill>
+            <a:srgbClr val="1F6F8B"/>
+          </a:solidFill>
+          <a:ln>
+            <a:noFill/>
+          </a:ln>
+          <a:effectLst/>
+        </p:spPr>
+        <p:txBody>
+          <a:bodyPr rtlCol="0" anchor="ctr"/>
+          <a:lstStyle/>
+          <a:p>
+            <a:pPr algn="ctr"/>
+          </a:p>
+        </p:txBody>
+      </p:sp>
+      <p:sp>
+        <p:nvSpPr>
+          <p:cNvPr id="16" name="TextBox 15"/>
+          <p:cNvSpPr txBox="1"/>
+          <p:nvPr/>
+        </p:nvSpPr>
+        <p:spPr>
+          <a:xfrm>
+            <a:off x="502920" y="2651760"/>
+            <a:ext cx="384048" cy="384048"/>
+          </a:xfrm>
+          <a:prstGeom prst="rect">
+            <a:avLst/>
+          </a:prstGeom>
+          <a:noFill/>
+          <a:ln/>
+        </p:spPr>
+        <p:txBody>
+          <a:bodyPr wrap="square" anchor="ctr" lIns="25400" rIns="25400" tIns="25400" bIns="25400">
+            <a:spAutoFit/>
+          </a:bodyPr>
+          <a:lstStyle/>
+          <a:p>
+            <a:pPr algn="ctr">
+              <a:lnSpc>
+                <a:spcPct val="100000"/>
+              </a:lnSpc>
+              <a:spcBef>
+                <a:spcPts val="0"/>
+              </a:spcBef>
+              <a:spcAft>
+                <a:spcPts val="0"/>
+              </a:spcAft>
+            </a:pPr>
+            <a:r>
+              <a:rPr sz="1400" b="1" i="0">
+                <a:solidFill>
+                  <a:srgbClr val="FFFFFF"/>
+                </a:solidFill>
+                <a:latin typeface="Arial"/>
+              </a:rPr>
+              <a:t>03</a:t>
+            </a:r>
+          </a:p>
+        </p:txBody>
+      </p:sp>
+      <p:sp>
+        <p:nvSpPr>
+          <p:cNvPr id="17" name="TextBox 16"/>
+          <p:cNvSpPr txBox="1"/>
+          <p:nvPr/>
+        </p:nvSpPr>
+        <p:spPr>
+          <a:xfrm>
+            <a:off x="1051560" y="2633472"/>
+            <a:ext cx="7589520" cy="292608"/>
+          </a:xfrm>
+          <a:prstGeom prst="rect">
+            <a:avLst/>
+          </a:prstGeom>
+          <a:noFill/>
+          <a:ln/>
+        </p:spPr>
+        <p:txBody>
+          <a:bodyPr wrap="square" anchor="t" lIns="25400" rIns="25400" tIns="25400" bIns="25400">
+            <a:spAutoFit/>
+          </a:bodyPr>
+          <a:lstStyle/>
+          <a:p>
+            <a:pPr algn="l">
+              <a:lnSpc>
+                <a:spcPct val="100000"/>
+              </a:lnSpc>
+              <a:spcBef>
+                <a:spcPts val="0"/>
+              </a:spcBef>
+              <a:spcAft>
+                <a:spcPts val="0"/>
+              </a:spcAft>
+            </a:pPr>
+            <a:r>
+              <a:rPr sz="1450" b="1" i="0">
+                <a:solidFill>
+                  <a:srgbClr val="16213E"/>
+                </a:solidFill>
+                <a:latin typeface="Arial"/>
+              </a:rPr>
+              <a:t>No forecast gain</a:t>
+            </a:r>
+          </a:p>
+        </p:txBody>
+      </p:sp>
+      <p:sp>
+        <p:nvSpPr>
+          <p:cNvPr id="18" name="TextBox 17"/>
+          <p:cNvSpPr txBox="1"/>
+          <p:nvPr/>
+        </p:nvSpPr>
+        <p:spPr>
+          <a:xfrm>
+            <a:off x="1051560" y="2926080"/>
+            <a:ext cx="7589520" cy="548640"/>
+          </a:xfrm>
+          <a:prstGeom prst="rect">
+            <a:avLst/>
+          </a:prstGeom>
+          <a:noFill/>
+          <a:ln/>
+        </p:spPr>
+        <p:txBody>
+          <a:bodyPr wrap="square" anchor="t" lIns="25400" rIns="25400" tIns="25400" bIns="25400">
+            <a:spAutoFit/>
+          </a:bodyPr>
+          <a:lstStyle/>
+          <a:p>
+            <a:pPr algn="l">
+              <a:lnSpc>
+                <a:spcPct val="102000"/>
+              </a:lnSpc>
+              <a:spcBef>
+                <a:spcPts val="0"/>
+              </a:spcBef>
+              <a:spcAft>
+                <a:spcPts val="0"/>
+              </a:spcAft>
+            </a:pPr>
+            <a:r>
+              <a:rPr sz="1150" b="0" i="0">
+                <a:solidFill>
+                  <a:srgbClr val="3D4A5C"/>
+                </a:solidFill>
+                <a:latin typeface="Arial"/>
+              </a:rPr>
+              <a:t>Lagged income growth did not improve out-of-sample forecasts in the panel (RMSE 3.77 vs 3.79).</a:t>
+            </a:r>
+          </a:p>
+        </p:txBody>
+      </p:sp>
+      <p:sp>
+        <p:nvSpPr>
+          <p:cNvPr id="19" name="Rounded Rectangle 18"/>
+          <p:cNvSpPr/>
+          <p:nvPr/>
+        </p:nvSpPr>
+        <p:spPr>
+          <a:xfrm>
+            <a:off x="502920" y="3310128"/>
+            <a:ext cx="384048" cy="384048"/>
+          </a:xfrm>
+          <a:prstGeom prst="roundRect">
+            <a:avLst>
+              <a:gd name="adj" fmla="val 50000"/>
+            </a:avLst>
+          </a:prstGeom>
+          <a:solidFill>
+            <a:srgbClr val="1F6F8B"/>
+          </a:solidFill>
+          <a:ln>
+            <a:noFill/>
+          </a:ln>
+          <a:effectLst/>
+        </p:spPr>
+        <p:txBody>
+          <a:bodyPr rtlCol="0" anchor="ctr"/>
+          <a:lstStyle/>
+          <a:p>
+            <a:pPr algn="ctr"/>
+          </a:p>
+        </p:txBody>
+      </p:sp>
+      <p:sp>
+        <p:nvSpPr>
+          <p:cNvPr id="20" name="TextBox 19"/>
+          <p:cNvSpPr txBox="1"/>
+          <p:nvPr/>
+        </p:nvSpPr>
+        <p:spPr>
+          <a:xfrm>
+            <a:off x="502920" y="3310128"/>
+            <a:ext cx="384048" cy="384048"/>
+          </a:xfrm>
+          <a:prstGeom prst="rect">
+            <a:avLst/>
+          </a:prstGeom>
+          <a:noFill/>
+          <a:ln/>
+        </p:spPr>
+        <p:txBody>
+          <a:bodyPr wrap="square" anchor="ctr" lIns="25400" rIns="25400" tIns="25400" bIns="25400">
+            <a:spAutoFit/>
+          </a:bodyPr>
+          <a:lstStyle/>
+          <a:p>
+            <a:pPr algn="ctr">
+              <a:lnSpc>
+                <a:spcPct val="100000"/>
+              </a:lnSpc>
+              <a:spcBef>
+                <a:spcPts val="0"/>
+              </a:spcBef>
+              <a:spcAft>
+                <a:spcPts val="0"/>
+              </a:spcAft>
+            </a:pPr>
+            <a:r>
+              <a:rPr sz="1400" b="1" i="0">
+                <a:solidFill>
+                  <a:srgbClr val="FFFFFF"/>
+                </a:solidFill>
+                <a:latin typeface="Arial"/>
+              </a:rPr>
+              <a:t>04</a:t>
+            </a:r>
+          </a:p>
+        </p:txBody>
+      </p:sp>
+      <p:sp>
+        <p:nvSpPr>
+          <p:cNvPr id="21" name="TextBox 20"/>
+          <p:cNvSpPr txBox="1"/>
+          <p:nvPr/>
+        </p:nvSpPr>
+        <p:spPr>
+          <a:xfrm>
+            <a:off x="1051560" y="3291840"/>
+            <a:ext cx="7589520" cy="292608"/>
+          </a:xfrm>
+          <a:prstGeom prst="rect">
+            <a:avLst/>
+          </a:prstGeom>
+          <a:noFill/>
+          <a:ln/>
+        </p:spPr>
+        <p:txBody>
+          <a:bodyPr wrap="square" anchor="t" lIns="25400" rIns="25400" tIns="25400" bIns="25400">
+            <a:spAutoFit/>
+          </a:bodyPr>
+          <a:lstStyle/>
+          <a:p>
+            <a:pPr algn="l">
+              <a:lnSpc>
+                <a:spcPct val="100000"/>
+              </a:lnSpc>
+              <a:spcBef>
+                <a:spcPts val="0"/>
+              </a:spcBef>
+              <a:spcAft>
+                <a:spcPts val="0"/>
+              </a:spcAft>
+            </a:pPr>
+            <a:r>
+              <a:rPr sz="1450" b="1" i="0">
+                <a:solidFill>
+                  <a:srgbClr val="16213E"/>
+                </a:solidFill>
+                <a:latin typeface="Arial"/>
+              </a:rPr>
+              <a:t>So ARIMAX uses the mortgage rate</a:t>
+            </a:r>
+          </a:p>
+        </p:txBody>
+      </p:sp>
+      <p:sp>
+        <p:nvSpPr>
+          <p:cNvPr id="22" name="TextBox 21"/>
+          <p:cNvSpPr txBox="1"/>
+          <p:nvPr/>
+        </p:nvSpPr>
+        <p:spPr>
+          <a:xfrm>
+            <a:off x="1051560" y="3584448"/>
+            <a:ext cx="7589520" cy="548640"/>
+          </a:xfrm>
+          <a:prstGeom prst="rect">
+            <a:avLst/>
+          </a:prstGeom>
+          <a:noFill/>
+          <a:ln/>
+        </p:spPr>
+        <p:txBody>
+          <a:bodyPr wrap="square" anchor="t" lIns="25400" rIns="25400" tIns="25400" bIns="25400">
+            <a:spAutoFit/>
+          </a:bodyPr>
+          <a:lstStyle/>
+          <a:p>
+            <a:pPr algn="l">
+              <a:lnSpc>
+                <a:spcPct val="102000"/>
+              </a:lnSpc>
+              <a:spcBef>
+                <a:spcPts val="0"/>
+              </a:spcBef>
+              <a:spcAft>
+                <a:spcPts val="0"/>
+              </a:spcAft>
+            </a:pPr>
+            <a:r>
+              <a:rPr sz="1150" b="0" i="0">
+                <a:solidFill>
+                  <a:srgbClr val="3D4A5C"/>
+                </a:solidFill>
+                <a:latin typeface="Arial"/>
+              </a:rPr>
+              <a:t>The rate is the one outside driver that is monthly, timely and leads prices.</a:t>
+            </a:r>
+          </a:p>
+        </p:txBody>
+      </p:sp>
     </p:spTree>
   </p:cSld>
   <p:clrMapOvr>

</xml_diff>

<commit_message>
New direction: LA price forecasting with AI as an alternative tool
- Deck: cover question, slide 6 framing, four takeaways; income appendix slide dropped
  (annual data doesn't fit the monthly ARIMAX); speaker notes trimmed to about 8 minutes.
- Notebook: trend check (all three LLMs), what-each-method-knew table, model one-liners,
  before/after inflation chart (fig 23); course references removed.

Co-Authored-By: Claude Opus 5.5 <noreply@anthropic.com>
Claude-Session: https://claude.ai/code/session_01MGxrqNkCGgpin2owaUrbi7
</commit_message>
<xml_diff>
--- a/slides/LA_home_values_appendix_crime.pptx
+++ b/slides/LA_home_values_appendix_crime.pptx
@@ -6,7 +6,6 @@
   </p:sldMasterIdLst>
   <p:sldIdLst>
     <p:sldId id="256" r:id="rId7"/>
-    <p:sldId id="257" r:id="rId9"/>
   </p:sldIdLst>
   <p:sldSz cx="9144000" cy="5143500" type="screen4x3"/>
   <p:notesSz cx="6858000" cy="9144000"/>
@@ -504,76 +503,6 @@
           <a:p>
             <a:r>
               <a:t>Appendix slide, only if Professor Yu asks about crime. Two reasons it is not in the main talk: it covers only part of our neighborhoods, and it does not help predict prices. LAPD data only covers the City of LA, so this is 91 neighborhoods. We counted crimes within 1.5 kilometers of each neighborhood per 1,000 residents, and split them into violent crime (murder, rape, robbery, aggravated assault) and property crime, using the FBI definitions so 2021 and 2025 count the same things. On the left, violent crime and home value go together strongly: safer neighborhoods cost more, correlation minus 0.68. But the question for forecasting is whether crime tells us anything beyond price. The middle and right panels compare neighborhoods at the same price level. Crime did not predict which neighborhoods fell more in 2022 and 2023, p equals 0.59, or which are rising over the last year, p equals 0.68. Without the price control, high-crime areas did grow less this year, but that is just because they are the cheaper areas, and cheaper areas grew less. Same answer for total crime and property crime.</a:t>
-            </a:r>
-          </a:p>
-        </p:txBody>
-      </p:sp>
-      <p:sp>
-        <p:nvSpPr>
-          <p:cNvPr id="4" name="Slide Number Placeholder 3"/>
-          <p:cNvSpPr>
-            <a:spLocks noGrp="1"/>
-          </p:cNvSpPr>
-          <p:nvPr>
-            <p:ph type="sldNum" idx="5" sz="quarter"/>
-          </p:nvPr>
-        </p:nvSpPr>
-        <p:spPr/>
-      </p:sp>
-    </p:spTree>
-  </p:cSld>
-  <p:clrMapOvr>
-    <a:masterClrMapping/>
-  </p:clrMapOvr>
-</p:notes>
-</file>
-
-<file path=ppt/notesSlides/notesSlide2.xml><?xml version="1.0" encoding="utf-8"?>
-<p:notes xmlns:a="http://schemas.openxmlformats.org/drawingml/2006/main" xmlns:p="http://schemas.openxmlformats.org/presentationml/2006/main" xmlns:r="http://schemas.openxmlformats.org/officeDocument/2006/relationships">
-  <p:cSld>
-    <p:spTree>
-      <p:nvGrpSpPr>
-        <p:cNvPr id="1" name=""/>
-        <p:cNvGrpSpPr/>
-        <p:nvPr/>
-      </p:nvGrpSpPr>
-      <p:grpSpPr>
-        <a:xfrm>
-          <a:off x="0" y="0"/>
-          <a:ext cx="0" cy="0"/>
-          <a:chOff x="0" y="0"/>
-          <a:chExt cx="0" cy="0"/>
-        </a:xfrm>
-      </p:grpSpPr>
-      <p:sp>
-        <p:nvSpPr>
-          <p:cNvPr id="2" name="Slide Image Placeholder 1"/>
-          <p:cNvSpPr>
-            <a:spLocks noGrp="1"/>
-          </p:cNvSpPr>
-          <p:nvPr>
-            <p:ph type="sldImg" idx="2"/>
-          </p:nvPr>
-        </p:nvSpPr>
-        <p:spPr/>
-      </p:sp>
-      <p:sp>
-        <p:nvSpPr>
-          <p:cNvPr id="3" name="Notes Placeholder 2"/>
-          <p:cNvSpPr>
-            <a:spLocks noGrp="1"/>
-          </p:cNvSpPr>
-          <p:nvPr>
-            <p:ph type="body" idx="3" sz="quarter"/>
-          </p:nvPr>
-        </p:nvSpPr>
-        <p:spPr/>
-        <p:txBody>
-          <a:bodyPr/>
-          <a:lstStyle/>
-          <a:p>
-            <a:r>
-              <a:t>Only if asked about income. We did use income, in the ZIP-level panel. We left it out of the monthly ARIMAX because IRS income is annual, only starts in 2011, and comes out with a lag, so it barely varies month to month. And when we tested lagged income growth out of sample in the panel, it did not help: RMSE 3.77 versus 3.79. So the monthly model uses the mortgage rate.</a:t>
             </a:r>
           </a:p>
         </p:txBody>
@@ -3942,926 +3871,6 @@
           </a:prstGeom>
         </p:spPr>
       </p:pic>
-    </p:spTree>
-  </p:cSld>
-  <p:clrMapOvr>
-    <a:masterClrMapping/>
-  </p:clrMapOvr>
-</p:sld>
-</file>
-
-<file path=ppt/slides/slide2.xml><?xml version="1.0" encoding="utf-8"?>
-<p:sld xmlns:a="http://schemas.openxmlformats.org/drawingml/2006/main" xmlns:p="http://schemas.openxmlformats.org/presentationml/2006/main" xmlns:r="http://schemas.openxmlformats.org/officeDocument/2006/relationships">
-  <p:cSld>
-    <p:bg>
-      <p:bgPr>
-        <a:solidFill>
-          <a:srgbClr val="FAF8F4"/>
-        </a:solidFill>
-        <a:effectLst/>
-      </p:bgPr>
-    </p:bg>
-    <p:spTree>
-      <p:nvGrpSpPr>
-        <p:cNvPr id="1" name=""/>
-        <p:cNvGrpSpPr/>
-        <p:nvPr/>
-      </p:nvGrpSpPr>
-      <p:grpSpPr/>
-      <p:sp>
-        <p:nvSpPr>
-          <p:cNvPr id="2" name="deckkit-chrome-title"/>
-          <p:cNvSpPr txBox="1"/>
-          <p:nvPr/>
-        </p:nvSpPr>
-        <p:spPr>
-          <a:xfrm>
-            <a:off x="502920" y="274320"/>
-            <a:ext cx="8138160" cy="274320"/>
-          </a:xfrm>
-          <a:prstGeom prst="rect">
-            <a:avLst/>
-          </a:prstGeom>
-          <a:noFill/>
-          <a:ln/>
-        </p:spPr>
-        <p:txBody>
-          <a:bodyPr wrap="square" anchor="t" lIns="25400" rIns="25400" tIns="25400" bIns="25400">
-            <a:spAutoFit/>
-          </a:bodyPr>
-          <a:lstStyle/>
-          <a:p>
-            <a:pPr algn="l">
-              <a:lnSpc>
-                <a:spcPct val="100000"/>
-              </a:lnSpc>
-              <a:spcBef>
-                <a:spcPts val="0"/>
-              </a:spcBef>
-              <a:spcAft>
-                <a:spcPts val="0"/>
-              </a:spcAft>
-            </a:pPr>
-            <a:r>
-              <a:rPr sz="1100" b="1" i="0">
-                <a:solidFill>
-                  <a:srgbClr val="1F6F8B"/>
-                </a:solidFill>
-                <a:latin typeface="Arial"/>
-              </a:rPr>
-              <a:t>APPENDIX · ONLY IF ASKED ABOUT INCOME</a:t>
-            </a:r>
-          </a:p>
-        </p:txBody>
-      </p:sp>
-      <p:sp>
-        <p:nvSpPr>
-          <p:cNvPr id="3" name="deckkit-chrome-title"/>
-          <p:cNvSpPr txBox="1"/>
-          <p:nvPr/>
-        </p:nvSpPr>
-        <p:spPr>
-          <a:xfrm>
-            <a:off x="502920" y="493776"/>
-            <a:ext cx="8138160" cy="640080"/>
-          </a:xfrm>
-          <a:prstGeom prst="rect">
-            <a:avLst/>
-          </a:prstGeom>
-          <a:noFill/>
-          <a:ln/>
-        </p:spPr>
-        <p:txBody>
-          <a:bodyPr wrap="square" anchor="t" lIns="25400" rIns="25400" tIns="25400" bIns="25400">
-            <a:spAutoFit/>
-          </a:bodyPr>
-          <a:lstStyle/>
-          <a:p>
-            <a:pPr algn="l">
-              <a:lnSpc>
-                <a:spcPct val="100000"/>
-              </a:lnSpc>
-              <a:spcBef>
-                <a:spcPts val="0"/>
-              </a:spcBef>
-              <a:spcAft>
-                <a:spcPts val="0"/>
-              </a:spcAft>
-            </a:pPr>
-            <a:r>
-              <a:rPr sz="2600" b="1" i="0">
-                <a:solidFill>
-                  <a:srgbClr val="16213E"/>
-                </a:solidFill>
-                <a:latin typeface="Arial"/>
-              </a:rPr>
-              <a:t>Why income is not in our monthly ARIMAX</a:t>
-            </a:r>
-          </a:p>
-        </p:txBody>
-      </p:sp>
-      <p:sp>
-        <p:nvSpPr>
-          <p:cNvPr id="4" name="deckkit-chrome-title"/>
-          <p:cNvSpPr/>
-          <p:nvPr/>
-        </p:nvSpPr>
-        <p:spPr>
-          <a:xfrm>
-            <a:off x="521207" y="1060704"/>
-            <a:ext cx="1005840" cy="41148"/>
-          </a:xfrm>
-          <a:prstGeom prst="rect">
-            <a:avLst/>
-          </a:prstGeom>
-          <a:solidFill>
-            <a:srgbClr val="1F6F8B"/>
-          </a:solidFill>
-          <a:ln>
-            <a:noFill/>
-          </a:ln>
-          <a:effectLst/>
-        </p:spPr>
-        <p:txBody>
-          <a:bodyPr rtlCol="0" anchor="ctr"/>
-          <a:lstStyle/>
-          <a:p>
-            <a:pPr algn="ctr"/>
-          </a:p>
-        </p:txBody>
-      </p:sp>
-      <p:sp>
-        <p:nvSpPr>
-          <p:cNvPr id="5" name="TextBox 4"/>
-          <p:cNvSpPr txBox="1"/>
-          <p:nvPr/>
-        </p:nvSpPr>
-        <p:spPr>
-          <a:xfrm>
-            <a:off x="502920" y="4823460"/>
-            <a:ext cx="5486400" cy="274320"/>
-          </a:xfrm>
-          <a:prstGeom prst="rect">
-            <a:avLst/>
-          </a:prstGeom>
-          <a:noFill/>
-          <a:ln/>
-        </p:spPr>
-        <p:txBody>
-          <a:bodyPr wrap="square" anchor="t" lIns="25400" rIns="25400" tIns="25400" bIns="25400">
-            <a:spAutoFit/>
-          </a:bodyPr>
-          <a:lstStyle/>
-          <a:p>
-            <a:pPr algn="l">
-              <a:lnSpc>
-                <a:spcPct val="100000"/>
-              </a:lnSpc>
-              <a:spcBef>
-                <a:spcPts val="0"/>
-              </a:spcBef>
-              <a:spcAft>
-                <a:spcPts val="0"/>
-              </a:spcAft>
-            </a:pPr>
-            <a:r>
-              <a:rPr sz="800" b="0" i="0">
-                <a:solidFill>
-                  <a:srgbClr val="6B6F76"/>
-                </a:solidFill>
-                <a:latin typeface="Arial"/>
-              </a:rPr>
-              <a:t>MGMTMSA 437 · Forecasting LA Home Values · Data: Zillow ZHVI, FRED, BLS</a:t>
-            </a:r>
-          </a:p>
-        </p:txBody>
-      </p:sp>
-      <p:sp>
-        <p:nvSpPr>
-          <p:cNvPr id="6" name="TextBox 5"/>
-          <p:cNvSpPr txBox="1"/>
-          <p:nvPr/>
-        </p:nvSpPr>
-        <p:spPr>
-          <a:xfrm>
-            <a:off x="8229600" y="4823460"/>
-            <a:ext cx="548640" cy="274320"/>
-          </a:xfrm>
-          <a:prstGeom prst="rect">
-            <a:avLst/>
-          </a:prstGeom>
-          <a:noFill/>
-          <a:ln/>
-        </p:spPr>
-        <p:txBody>
-          <a:bodyPr wrap="square" anchor="t" lIns="25400" rIns="25400" tIns="25400" bIns="25400">
-            <a:spAutoFit/>
-          </a:bodyPr>
-          <a:lstStyle/>
-          <a:p>
-            <a:pPr algn="r">
-              <a:lnSpc>
-                <a:spcPct val="100000"/>
-              </a:lnSpc>
-              <a:spcBef>
-                <a:spcPts val="0"/>
-              </a:spcBef>
-              <a:spcAft>
-                <a:spcPts val="0"/>
-              </a:spcAft>
-            </a:pPr>
-            <a:r>
-              <a:rPr sz="900" b="1" i="0">
-                <a:solidFill>
-                  <a:srgbClr val="6B6F76"/>
-                </a:solidFill>
-                <a:latin typeface="Arial"/>
-              </a:rPr>
-              <a:t>2</a:t>
-            </a:r>
-          </a:p>
-        </p:txBody>
-      </p:sp>
-      <p:sp>
-        <p:nvSpPr>
-          <p:cNvPr id="7" name="Rounded Rectangle 6"/>
-          <p:cNvSpPr/>
-          <p:nvPr/>
-        </p:nvSpPr>
-        <p:spPr>
-          <a:xfrm>
-            <a:off x="502920" y="1335024"/>
-            <a:ext cx="384048" cy="384048"/>
-          </a:xfrm>
-          <a:prstGeom prst="roundRect">
-            <a:avLst>
-              <a:gd name="adj" fmla="val 50000"/>
-            </a:avLst>
-          </a:prstGeom>
-          <a:solidFill>
-            <a:srgbClr val="1F6F8B"/>
-          </a:solidFill>
-          <a:ln>
-            <a:noFill/>
-          </a:ln>
-          <a:effectLst/>
-        </p:spPr>
-        <p:txBody>
-          <a:bodyPr rtlCol="0" anchor="ctr"/>
-          <a:lstStyle/>
-          <a:p>
-            <a:pPr algn="ctr"/>
-          </a:p>
-        </p:txBody>
-      </p:sp>
-      <p:sp>
-        <p:nvSpPr>
-          <p:cNvPr id="8" name="TextBox 7"/>
-          <p:cNvSpPr txBox="1"/>
-          <p:nvPr/>
-        </p:nvSpPr>
-        <p:spPr>
-          <a:xfrm>
-            <a:off x="502920" y="1335024"/>
-            <a:ext cx="384048" cy="384048"/>
-          </a:xfrm>
-          <a:prstGeom prst="rect">
-            <a:avLst/>
-          </a:prstGeom>
-          <a:noFill/>
-          <a:ln/>
-        </p:spPr>
-        <p:txBody>
-          <a:bodyPr wrap="square" anchor="ctr" lIns="25400" rIns="25400" tIns="25400" bIns="25400">
-            <a:spAutoFit/>
-          </a:bodyPr>
-          <a:lstStyle/>
-          <a:p>
-            <a:pPr algn="ctr">
-              <a:lnSpc>
-                <a:spcPct val="100000"/>
-              </a:lnSpc>
-              <a:spcBef>
-                <a:spcPts val="0"/>
-              </a:spcBef>
-              <a:spcAft>
-                <a:spcPts val="0"/>
-              </a:spcAft>
-            </a:pPr>
-            <a:r>
-              <a:rPr sz="1400" b="1" i="0">
-                <a:solidFill>
-                  <a:srgbClr val="FFFFFF"/>
-                </a:solidFill>
-                <a:latin typeface="Arial"/>
-              </a:rPr>
-              <a:t>01</a:t>
-            </a:r>
-          </a:p>
-        </p:txBody>
-      </p:sp>
-      <p:sp>
-        <p:nvSpPr>
-          <p:cNvPr id="9" name="TextBox 8"/>
-          <p:cNvSpPr txBox="1"/>
-          <p:nvPr/>
-        </p:nvSpPr>
-        <p:spPr>
-          <a:xfrm>
-            <a:off x="1051560" y="1316736"/>
-            <a:ext cx="7589520" cy="292608"/>
-          </a:xfrm>
-          <a:prstGeom prst="rect">
-            <a:avLst/>
-          </a:prstGeom>
-          <a:noFill/>
-          <a:ln/>
-        </p:spPr>
-        <p:txBody>
-          <a:bodyPr wrap="square" anchor="t" lIns="25400" rIns="25400" tIns="25400" bIns="25400">
-            <a:spAutoFit/>
-          </a:bodyPr>
-          <a:lstStyle/>
-          <a:p>
-            <a:pPr algn="l">
-              <a:lnSpc>
-                <a:spcPct val="100000"/>
-              </a:lnSpc>
-              <a:spcBef>
-                <a:spcPts val="0"/>
-              </a:spcBef>
-              <a:spcAft>
-                <a:spcPts val="0"/>
-              </a:spcAft>
-            </a:pPr>
-            <a:r>
-              <a:rPr sz="1450" b="1" i="0">
-                <a:solidFill>
-                  <a:srgbClr val="16213E"/>
-                </a:solidFill>
-                <a:latin typeface="Arial"/>
-              </a:rPr>
-              <a:t>Used in the ZIP-level panel</a:t>
-            </a:r>
-          </a:p>
-        </p:txBody>
-      </p:sp>
-      <p:sp>
-        <p:nvSpPr>
-          <p:cNvPr id="10" name="TextBox 9"/>
-          <p:cNvSpPr txBox="1"/>
-          <p:nvPr/>
-        </p:nvSpPr>
-        <p:spPr>
-          <a:xfrm>
-            <a:off x="1051560" y="1609344"/>
-            <a:ext cx="7589520" cy="548640"/>
-          </a:xfrm>
-          <a:prstGeom prst="rect">
-            <a:avLst/>
-          </a:prstGeom>
-          <a:noFill/>
-          <a:ln/>
-        </p:spPr>
-        <p:txBody>
-          <a:bodyPr wrap="square" anchor="t" lIns="25400" rIns="25400" tIns="25400" bIns="25400">
-            <a:spAutoFit/>
-          </a:bodyPr>
-          <a:lstStyle/>
-          <a:p>
-            <a:pPr algn="l">
-              <a:lnSpc>
-                <a:spcPct val="102000"/>
-              </a:lnSpc>
-              <a:spcBef>
-                <a:spcPts val="0"/>
-              </a:spcBef>
-              <a:spcAft>
-                <a:spcPts val="0"/>
-              </a:spcAft>
-            </a:pPr>
-            <a:r>
-              <a:rPr sz="1150" b="0" i="0">
-                <a:solidFill>
-                  <a:srgbClr val="3D4A5C"/>
-                </a:solidFill>
-                <a:latin typeface="Arial"/>
-              </a:rPr>
-              <a:t>Income enters the cross-sectional panel analysis across ZIP codes.</a:t>
-            </a:r>
-          </a:p>
-        </p:txBody>
-      </p:sp>
-      <p:sp>
-        <p:nvSpPr>
-          <p:cNvPr id="11" name="Rounded Rectangle 10"/>
-          <p:cNvSpPr/>
-          <p:nvPr/>
-        </p:nvSpPr>
-        <p:spPr>
-          <a:xfrm>
-            <a:off x="502920" y="1993392"/>
-            <a:ext cx="384048" cy="384048"/>
-          </a:xfrm>
-          <a:prstGeom prst="roundRect">
-            <a:avLst>
-              <a:gd name="adj" fmla="val 50000"/>
-            </a:avLst>
-          </a:prstGeom>
-          <a:solidFill>
-            <a:srgbClr val="1F6F8B"/>
-          </a:solidFill>
-          <a:ln>
-            <a:noFill/>
-          </a:ln>
-          <a:effectLst/>
-        </p:spPr>
-        <p:txBody>
-          <a:bodyPr rtlCol="0" anchor="ctr"/>
-          <a:lstStyle/>
-          <a:p>
-            <a:pPr algn="ctr"/>
-          </a:p>
-        </p:txBody>
-      </p:sp>
-      <p:sp>
-        <p:nvSpPr>
-          <p:cNvPr id="12" name="TextBox 11"/>
-          <p:cNvSpPr txBox="1"/>
-          <p:nvPr/>
-        </p:nvSpPr>
-        <p:spPr>
-          <a:xfrm>
-            <a:off x="502920" y="1993392"/>
-            <a:ext cx="384048" cy="384048"/>
-          </a:xfrm>
-          <a:prstGeom prst="rect">
-            <a:avLst/>
-          </a:prstGeom>
-          <a:noFill/>
-          <a:ln/>
-        </p:spPr>
-        <p:txBody>
-          <a:bodyPr wrap="square" anchor="ctr" lIns="25400" rIns="25400" tIns="25400" bIns="25400">
-            <a:spAutoFit/>
-          </a:bodyPr>
-          <a:lstStyle/>
-          <a:p>
-            <a:pPr algn="ctr">
-              <a:lnSpc>
-                <a:spcPct val="100000"/>
-              </a:lnSpc>
-              <a:spcBef>
-                <a:spcPts val="0"/>
-              </a:spcBef>
-              <a:spcAft>
-                <a:spcPts val="0"/>
-              </a:spcAft>
-            </a:pPr>
-            <a:r>
-              <a:rPr sz="1400" b="1" i="0">
-                <a:solidFill>
-                  <a:srgbClr val="FFFFFF"/>
-                </a:solidFill>
-                <a:latin typeface="Arial"/>
-              </a:rPr>
-              <a:t>02</a:t>
-            </a:r>
-          </a:p>
-        </p:txBody>
-      </p:sp>
-      <p:sp>
-        <p:nvSpPr>
-          <p:cNvPr id="13" name="TextBox 12"/>
-          <p:cNvSpPr txBox="1"/>
-          <p:nvPr/>
-        </p:nvSpPr>
-        <p:spPr>
-          <a:xfrm>
-            <a:off x="1051560" y="1975104"/>
-            <a:ext cx="7589520" cy="292608"/>
-          </a:xfrm>
-          <a:prstGeom prst="rect">
-            <a:avLst/>
-          </a:prstGeom>
-          <a:noFill/>
-          <a:ln/>
-        </p:spPr>
-        <p:txBody>
-          <a:bodyPr wrap="square" anchor="t" lIns="25400" rIns="25400" tIns="25400" bIns="25400">
-            <a:spAutoFit/>
-          </a:bodyPr>
-          <a:lstStyle/>
-          <a:p>
-            <a:pPr algn="l">
-              <a:lnSpc>
-                <a:spcPct val="100000"/>
-              </a:lnSpc>
-              <a:spcBef>
-                <a:spcPts val="0"/>
-              </a:spcBef>
-              <a:spcAft>
-                <a:spcPts val="0"/>
-              </a:spcAft>
-            </a:pPr>
-            <a:r>
-              <a:rPr sz="1450" b="1" i="0">
-                <a:solidFill>
-                  <a:srgbClr val="16213E"/>
-                </a:solidFill>
-                <a:latin typeface="Arial"/>
-              </a:rPr>
-              <a:t>Too slow for a monthly model</a:t>
-            </a:r>
-          </a:p>
-        </p:txBody>
-      </p:sp>
-      <p:sp>
-        <p:nvSpPr>
-          <p:cNvPr id="14" name="TextBox 13"/>
-          <p:cNvSpPr txBox="1"/>
-          <p:nvPr/>
-        </p:nvSpPr>
-        <p:spPr>
-          <a:xfrm>
-            <a:off x="1051560" y="2267712"/>
-            <a:ext cx="7589520" cy="548640"/>
-          </a:xfrm>
-          <a:prstGeom prst="rect">
-            <a:avLst/>
-          </a:prstGeom>
-          <a:noFill/>
-          <a:ln/>
-        </p:spPr>
-        <p:txBody>
-          <a:bodyPr wrap="square" anchor="t" lIns="25400" rIns="25400" tIns="25400" bIns="25400">
-            <a:spAutoFit/>
-          </a:bodyPr>
-          <a:lstStyle/>
-          <a:p>
-            <a:pPr algn="l">
-              <a:lnSpc>
-                <a:spcPct val="102000"/>
-              </a:lnSpc>
-              <a:spcBef>
-                <a:spcPts val="0"/>
-              </a:spcBef>
-              <a:spcAft>
-                <a:spcPts val="0"/>
-              </a:spcAft>
-            </a:pPr>
-            <a:r>
-              <a:rPr sz="1150" b="0" i="0">
-                <a:solidFill>
-                  <a:srgbClr val="3D4A5C"/>
-                </a:solidFill>
-                <a:latin typeface="Arial"/>
-              </a:rPr>
-              <a:t>IRS income is annual, starts in 2011 and is released with a lag, so it adds little month-to-month variation.</a:t>
-            </a:r>
-          </a:p>
-        </p:txBody>
-      </p:sp>
-      <p:sp>
-        <p:nvSpPr>
-          <p:cNvPr id="15" name="Rounded Rectangle 14"/>
-          <p:cNvSpPr/>
-          <p:nvPr/>
-        </p:nvSpPr>
-        <p:spPr>
-          <a:xfrm>
-            <a:off x="502920" y="2651760"/>
-            <a:ext cx="384048" cy="384048"/>
-          </a:xfrm>
-          <a:prstGeom prst="roundRect">
-            <a:avLst>
-              <a:gd name="adj" fmla="val 50000"/>
-            </a:avLst>
-          </a:prstGeom>
-          <a:solidFill>
-            <a:srgbClr val="1F6F8B"/>
-          </a:solidFill>
-          <a:ln>
-            <a:noFill/>
-          </a:ln>
-          <a:effectLst/>
-        </p:spPr>
-        <p:txBody>
-          <a:bodyPr rtlCol="0" anchor="ctr"/>
-          <a:lstStyle/>
-          <a:p>
-            <a:pPr algn="ctr"/>
-          </a:p>
-        </p:txBody>
-      </p:sp>
-      <p:sp>
-        <p:nvSpPr>
-          <p:cNvPr id="16" name="TextBox 15"/>
-          <p:cNvSpPr txBox="1"/>
-          <p:nvPr/>
-        </p:nvSpPr>
-        <p:spPr>
-          <a:xfrm>
-            <a:off x="502920" y="2651760"/>
-            <a:ext cx="384048" cy="384048"/>
-          </a:xfrm>
-          <a:prstGeom prst="rect">
-            <a:avLst/>
-          </a:prstGeom>
-          <a:noFill/>
-          <a:ln/>
-        </p:spPr>
-        <p:txBody>
-          <a:bodyPr wrap="square" anchor="ctr" lIns="25400" rIns="25400" tIns="25400" bIns="25400">
-            <a:spAutoFit/>
-          </a:bodyPr>
-          <a:lstStyle/>
-          <a:p>
-            <a:pPr algn="ctr">
-              <a:lnSpc>
-                <a:spcPct val="100000"/>
-              </a:lnSpc>
-              <a:spcBef>
-                <a:spcPts val="0"/>
-              </a:spcBef>
-              <a:spcAft>
-                <a:spcPts val="0"/>
-              </a:spcAft>
-            </a:pPr>
-            <a:r>
-              <a:rPr sz="1400" b="1" i="0">
-                <a:solidFill>
-                  <a:srgbClr val="FFFFFF"/>
-                </a:solidFill>
-                <a:latin typeface="Arial"/>
-              </a:rPr>
-              <a:t>03</a:t>
-            </a:r>
-          </a:p>
-        </p:txBody>
-      </p:sp>
-      <p:sp>
-        <p:nvSpPr>
-          <p:cNvPr id="17" name="TextBox 16"/>
-          <p:cNvSpPr txBox="1"/>
-          <p:nvPr/>
-        </p:nvSpPr>
-        <p:spPr>
-          <a:xfrm>
-            <a:off x="1051560" y="2633472"/>
-            <a:ext cx="7589520" cy="292608"/>
-          </a:xfrm>
-          <a:prstGeom prst="rect">
-            <a:avLst/>
-          </a:prstGeom>
-          <a:noFill/>
-          <a:ln/>
-        </p:spPr>
-        <p:txBody>
-          <a:bodyPr wrap="square" anchor="t" lIns="25400" rIns="25400" tIns="25400" bIns="25400">
-            <a:spAutoFit/>
-          </a:bodyPr>
-          <a:lstStyle/>
-          <a:p>
-            <a:pPr algn="l">
-              <a:lnSpc>
-                <a:spcPct val="100000"/>
-              </a:lnSpc>
-              <a:spcBef>
-                <a:spcPts val="0"/>
-              </a:spcBef>
-              <a:spcAft>
-                <a:spcPts val="0"/>
-              </a:spcAft>
-            </a:pPr>
-            <a:r>
-              <a:rPr sz="1450" b="1" i="0">
-                <a:solidFill>
-                  <a:srgbClr val="16213E"/>
-                </a:solidFill>
-                <a:latin typeface="Arial"/>
-              </a:rPr>
-              <a:t>No forecast gain</a:t>
-            </a:r>
-          </a:p>
-        </p:txBody>
-      </p:sp>
-      <p:sp>
-        <p:nvSpPr>
-          <p:cNvPr id="18" name="TextBox 17"/>
-          <p:cNvSpPr txBox="1"/>
-          <p:nvPr/>
-        </p:nvSpPr>
-        <p:spPr>
-          <a:xfrm>
-            <a:off x="1051560" y="2926080"/>
-            <a:ext cx="7589520" cy="548640"/>
-          </a:xfrm>
-          <a:prstGeom prst="rect">
-            <a:avLst/>
-          </a:prstGeom>
-          <a:noFill/>
-          <a:ln/>
-        </p:spPr>
-        <p:txBody>
-          <a:bodyPr wrap="square" anchor="t" lIns="25400" rIns="25400" tIns="25400" bIns="25400">
-            <a:spAutoFit/>
-          </a:bodyPr>
-          <a:lstStyle/>
-          <a:p>
-            <a:pPr algn="l">
-              <a:lnSpc>
-                <a:spcPct val="102000"/>
-              </a:lnSpc>
-              <a:spcBef>
-                <a:spcPts val="0"/>
-              </a:spcBef>
-              <a:spcAft>
-                <a:spcPts val="0"/>
-              </a:spcAft>
-            </a:pPr>
-            <a:r>
-              <a:rPr sz="1150" b="0" i="0">
-                <a:solidFill>
-                  <a:srgbClr val="3D4A5C"/>
-                </a:solidFill>
-                <a:latin typeface="Arial"/>
-              </a:rPr>
-              <a:t>Lagged income growth did not improve out-of-sample forecasts in the panel (RMSE 3.77 vs 3.79).</a:t>
-            </a:r>
-          </a:p>
-        </p:txBody>
-      </p:sp>
-      <p:sp>
-        <p:nvSpPr>
-          <p:cNvPr id="19" name="Rounded Rectangle 18"/>
-          <p:cNvSpPr/>
-          <p:nvPr/>
-        </p:nvSpPr>
-        <p:spPr>
-          <a:xfrm>
-            <a:off x="502920" y="3310128"/>
-            <a:ext cx="384048" cy="384048"/>
-          </a:xfrm>
-          <a:prstGeom prst="roundRect">
-            <a:avLst>
-              <a:gd name="adj" fmla="val 50000"/>
-            </a:avLst>
-          </a:prstGeom>
-          <a:solidFill>
-            <a:srgbClr val="1F6F8B"/>
-          </a:solidFill>
-          <a:ln>
-            <a:noFill/>
-          </a:ln>
-          <a:effectLst/>
-        </p:spPr>
-        <p:txBody>
-          <a:bodyPr rtlCol="0" anchor="ctr"/>
-          <a:lstStyle/>
-          <a:p>
-            <a:pPr algn="ctr"/>
-          </a:p>
-        </p:txBody>
-      </p:sp>
-      <p:sp>
-        <p:nvSpPr>
-          <p:cNvPr id="20" name="TextBox 19"/>
-          <p:cNvSpPr txBox="1"/>
-          <p:nvPr/>
-        </p:nvSpPr>
-        <p:spPr>
-          <a:xfrm>
-            <a:off x="502920" y="3310128"/>
-            <a:ext cx="384048" cy="384048"/>
-          </a:xfrm>
-          <a:prstGeom prst="rect">
-            <a:avLst/>
-          </a:prstGeom>
-          <a:noFill/>
-          <a:ln/>
-        </p:spPr>
-        <p:txBody>
-          <a:bodyPr wrap="square" anchor="ctr" lIns="25400" rIns="25400" tIns="25400" bIns="25400">
-            <a:spAutoFit/>
-          </a:bodyPr>
-          <a:lstStyle/>
-          <a:p>
-            <a:pPr algn="ctr">
-              <a:lnSpc>
-                <a:spcPct val="100000"/>
-              </a:lnSpc>
-              <a:spcBef>
-                <a:spcPts val="0"/>
-              </a:spcBef>
-              <a:spcAft>
-                <a:spcPts val="0"/>
-              </a:spcAft>
-            </a:pPr>
-            <a:r>
-              <a:rPr sz="1400" b="1" i="0">
-                <a:solidFill>
-                  <a:srgbClr val="FFFFFF"/>
-                </a:solidFill>
-                <a:latin typeface="Arial"/>
-              </a:rPr>
-              <a:t>04</a:t>
-            </a:r>
-          </a:p>
-        </p:txBody>
-      </p:sp>
-      <p:sp>
-        <p:nvSpPr>
-          <p:cNvPr id="21" name="TextBox 20"/>
-          <p:cNvSpPr txBox="1"/>
-          <p:nvPr/>
-        </p:nvSpPr>
-        <p:spPr>
-          <a:xfrm>
-            <a:off x="1051560" y="3291840"/>
-            <a:ext cx="7589520" cy="292608"/>
-          </a:xfrm>
-          <a:prstGeom prst="rect">
-            <a:avLst/>
-          </a:prstGeom>
-          <a:noFill/>
-          <a:ln/>
-        </p:spPr>
-        <p:txBody>
-          <a:bodyPr wrap="square" anchor="t" lIns="25400" rIns="25400" tIns="25400" bIns="25400">
-            <a:spAutoFit/>
-          </a:bodyPr>
-          <a:lstStyle/>
-          <a:p>
-            <a:pPr algn="l">
-              <a:lnSpc>
-                <a:spcPct val="100000"/>
-              </a:lnSpc>
-              <a:spcBef>
-                <a:spcPts val="0"/>
-              </a:spcBef>
-              <a:spcAft>
-                <a:spcPts val="0"/>
-              </a:spcAft>
-            </a:pPr>
-            <a:r>
-              <a:rPr sz="1450" b="1" i="0">
-                <a:solidFill>
-                  <a:srgbClr val="16213E"/>
-                </a:solidFill>
-                <a:latin typeface="Arial"/>
-              </a:rPr>
-              <a:t>So ARIMAX uses the mortgage rate</a:t>
-            </a:r>
-          </a:p>
-        </p:txBody>
-      </p:sp>
-      <p:sp>
-        <p:nvSpPr>
-          <p:cNvPr id="22" name="TextBox 21"/>
-          <p:cNvSpPr txBox="1"/>
-          <p:nvPr/>
-        </p:nvSpPr>
-        <p:spPr>
-          <a:xfrm>
-            <a:off x="1051560" y="3584448"/>
-            <a:ext cx="7589520" cy="548640"/>
-          </a:xfrm>
-          <a:prstGeom prst="rect">
-            <a:avLst/>
-          </a:prstGeom>
-          <a:noFill/>
-          <a:ln/>
-        </p:spPr>
-        <p:txBody>
-          <a:bodyPr wrap="square" anchor="t" lIns="25400" rIns="25400" tIns="25400" bIns="25400">
-            <a:spAutoFit/>
-          </a:bodyPr>
-          <a:lstStyle/>
-          <a:p>
-            <a:pPr algn="l">
-              <a:lnSpc>
-                <a:spcPct val="102000"/>
-              </a:lnSpc>
-              <a:spcBef>
-                <a:spcPts val="0"/>
-              </a:spcBef>
-              <a:spcAft>
-                <a:spcPts val="0"/>
-              </a:spcAft>
-            </a:pPr>
-            <a:r>
-              <a:rPr sz="1150" b="0" i="0">
-                <a:solidFill>
-                  <a:srgbClr val="3D4A5C"/>
-                </a:solidFill>
-                <a:latin typeface="Arial"/>
-              </a:rPr>
-              <a:t>The rate is the one outside driver that is monthly, timely and leads prices.</a:t>
-            </a:r>
-          </a:p>
-        </p:txBody>
-      </p:sp>
     </p:spTree>
   </p:cSld>
   <p:clrMapOvr>

</xml_diff>